<commit_message>
doc: add presentation v1.0
</commit_message>
<xml_diff>
--- a/presentation/ByteForce_Bärnhäckt.pptx
+++ b/presentation/ByteForce_Bärnhäckt.pptx
@@ -5,7 +5,8 @@
     <p:sldMasterId id="2147483648" r:id="rId1"/>
   </p:sldMasterIdLst>
   <p:sldIdLst>
-    <p:sldId id="256" r:id="rId2"/>
+    <p:sldId id="258" r:id="rId2"/>
+    <p:sldId id="259" r:id="rId3"/>
   </p:sldIdLst>
   <p:sldSz cx="12192000" cy="6858000"/>
   <p:notesSz cx="6858000" cy="9144000"/>
@@ -3328,14 +3329,6 @@
 <file path=ppt/slides/slide1.xml><?xml version="1.0" encoding="utf-8"?>
 <p:sld xmlns:a="http://schemas.openxmlformats.org/drawingml/2006/main" xmlns:r="http://schemas.openxmlformats.org/officeDocument/2006/relationships" xmlns:p="http://schemas.openxmlformats.org/presentationml/2006/main">
   <p:cSld>
-    <p:bg>
-      <p:bgPr>
-        <a:solidFill>
-          <a:schemeClr val="bg1"/>
-        </a:solidFill>
-        <a:effectLst/>
-      </p:bgPr>
-    </p:bg>
     <p:spTree>
       <p:nvGrpSpPr>
         <p:cNvPr id="1" name=""/>
@@ -3350,167 +3343,12 @@
           <a:chExt cx="0" cy="0"/>
         </a:xfrm>
       </p:grpSpPr>
-      <p:sp>
-        <p:nvSpPr>
-          <p:cNvPr id="10" name="Rectangle 9">
-            <a:extLst>
-              <a:ext uri="{FF2B5EF4-FFF2-40B4-BE49-F238E27FC236}">
-                <a16:creationId xmlns:a16="http://schemas.microsoft.com/office/drawing/2014/main" id="{42A4FC2C-047E-45A5-965D-8E1E3BF09BC6}"/>
-              </a:ext>
-              <a:ext uri="{C183D7F6-B498-43B3-948B-1728B52AA6E4}">
-                <adec:decorative xmlns:adec="http://schemas.microsoft.com/office/drawing/2017/decorative" val="1"/>
-              </a:ext>
-            </a:extLst>
-          </p:cNvPr>
-          <p:cNvSpPr>
-            <a:spLocks noGrp="1" noRot="1" noChangeAspect="1" noMove="1" noResize="1" noEditPoints="1" noAdjustHandles="1" noChangeArrowheads="1" noChangeShapeType="1" noTextEdit="1"/>
-          </p:cNvSpPr>
-          <p:nvPr>
-            <p:extLst>
-              <p:ext uri="{386F3935-93C4-4BCD-93E2-E3B085C9AB24}">
-                <p16:designElem xmlns:p16="http://schemas.microsoft.com/office/powerpoint/2015/main" val="1"/>
-              </p:ext>
-            </p:extLst>
-          </p:nvPr>
-        </p:nvSpPr>
-        <p:spPr bwMode="white">
-          <a:xfrm>
-            <a:off x="1524" y="0"/>
-            <a:ext cx="12188952" cy="6858000"/>
-          </a:xfrm>
-          <a:prstGeom prst="rect">
-            <a:avLst/>
-          </a:prstGeom>
-          <a:noFill/>
-          <a:ln>
-            <a:noFill/>
-          </a:ln>
-        </p:spPr>
-        <p:style>
-          <a:lnRef idx="2">
-            <a:schemeClr val="accent1">
-              <a:shade val="50000"/>
-            </a:schemeClr>
-          </a:lnRef>
-          <a:fillRef idx="1">
-            <a:schemeClr val="accent1"/>
-          </a:fillRef>
-          <a:effectRef idx="0">
-            <a:schemeClr val="accent1"/>
-          </a:effectRef>
-          <a:fontRef idx="minor">
-            <a:schemeClr val="lt1"/>
-          </a:fontRef>
-        </p:style>
-        <p:txBody>
-          <a:bodyPr rtlCol="0" anchor="ctr"/>
-          <a:lstStyle>
-            <a:defPPr>
-              <a:defRPr lang="en-US"/>
-            </a:defPPr>
-            <a:lvl1pPr marL="0" algn="l" defTabSz="914400" rtl="0" eaLnBrk="1" latinLnBrk="0" hangingPunct="1">
-              <a:defRPr sz="1800" kern="1200">
-                <a:solidFill>
-                  <a:schemeClr val="lt1"/>
-                </a:solidFill>
-                <a:latin typeface="+mn-lt"/>
-                <a:ea typeface="+mn-ea"/>
-                <a:cs typeface="+mn-cs"/>
-              </a:defRPr>
-            </a:lvl1pPr>
-            <a:lvl2pPr marL="457200" algn="l" defTabSz="914400" rtl="0" eaLnBrk="1" latinLnBrk="0" hangingPunct="1">
-              <a:defRPr sz="1800" kern="1200">
-                <a:solidFill>
-                  <a:schemeClr val="lt1"/>
-                </a:solidFill>
-                <a:latin typeface="+mn-lt"/>
-                <a:ea typeface="+mn-ea"/>
-                <a:cs typeface="+mn-cs"/>
-              </a:defRPr>
-            </a:lvl2pPr>
-            <a:lvl3pPr marL="914400" algn="l" defTabSz="914400" rtl="0" eaLnBrk="1" latinLnBrk="0" hangingPunct="1">
-              <a:defRPr sz="1800" kern="1200">
-                <a:solidFill>
-                  <a:schemeClr val="lt1"/>
-                </a:solidFill>
-                <a:latin typeface="+mn-lt"/>
-                <a:ea typeface="+mn-ea"/>
-                <a:cs typeface="+mn-cs"/>
-              </a:defRPr>
-            </a:lvl3pPr>
-            <a:lvl4pPr marL="1371600" algn="l" defTabSz="914400" rtl="0" eaLnBrk="1" latinLnBrk="0" hangingPunct="1">
-              <a:defRPr sz="1800" kern="1200">
-                <a:solidFill>
-                  <a:schemeClr val="lt1"/>
-                </a:solidFill>
-                <a:latin typeface="+mn-lt"/>
-                <a:ea typeface="+mn-ea"/>
-                <a:cs typeface="+mn-cs"/>
-              </a:defRPr>
-            </a:lvl4pPr>
-            <a:lvl5pPr marL="1828800" algn="l" defTabSz="914400" rtl="0" eaLnBrk="1" latinLnBrk="0" hangingPunct="1">
-              <a:defRPr sz="1800" kern="1200">
-                <a:solidFill>
-                  <a:schemeClr val="lt1"/>
-                </a:solidFill>
-                <a:latin typeface="+mn-lt"/>
-                <a:ea typeface="+mn-ea"/>
-                <a:cs typeface="+mn-cs"/>
-              </a:defRPr>
-            </a:lvl5pPr>
-            <a:lvl6pPr marL="2286000" algn="l" defTabSz="914400" rtl="0" eaLnBrk="1" latinLnBrk="0" hangingPunct="1">
-              <a:defRPr sz="1800" kern="1200">
-                <a:solidFill>
-                  <a:schemeClr val="lt1"/>
-                </a:solidFill>
-                <a:latin typeface="+mn-lt"/>
-                <a:ea typeface="+mn-ea"/>
-                <a:cs typeface="+mn-cs"/>
-              </a:defRPr>
-            </a:lvl6pPr>
-            <a:lvl7pPr marL="2743200" algn="l" defTabSz="914400" rtl="0" eaLnBrk="1" latinLnBrk="0" hangingPunct="1">
-              <a:defRPr sz="1800" kern="1200">
-                <a:solidFill>
-                  <a:schemeClr val="lt1"/>
-                </a:solidFill>
-                <a:latin typeface="+mn-lt"/>
-                <a:ea typeface="+mn-ea"/>
-                <a:cs typeface="+mn-cs"/>
-              </a:defRPr>
-            </a:lvl7pPr>
-            <a:lvl8pPr marL="3200400" algn="l" defTabSz="914400" rtl="0" eaLnBrk="1" latinLnBrk="0" hangingPunct="1">
-              <a:defRPr sz="1800" kern="1200">
-                <a:solidFill>
-                  <a:schemeClr val="lt1"/>
-                </a:solidFill>
-                <a:latin typeface="+mn-lt"/>
-                <a:ea typeface="+mn-ea"/>
-                <a:cs typeface="+mn-cs"/>
-              </a:defRPr>
-            </a:lvl8pPr>
-            <a:lvl9pPr marL="3657600" algn="l" defTabSz="914400" rtl="0" eaLnBrk="1" latinLnBrk="0" hangingPunct="1">
-              <a:defRPr sz="1800" kern="1200">
-                <a:solidFill>
-                  <a:schemeClr val="lt1"/>
-                </a:solidFill>
-                <a:latin typeface="+mn-lt"/>
-                <a:ea typeface="+mn-ea"/>
-                <a:cs typeface="+mn-cs"/>
-              </a:defRPr>
-            </a:lvl9pPr>
-          </a:lstStyle>
-          <a:p>
-            <a:pPr algn="ctr"/>
-            <a:endParaRPr lang="en-US"/>
-          </a:p>
-        </p:txBody>
-      </p:sp>
       <p:pic>
         <p:nvPicPr>
-          <p:cNvPr id="7" name="Grafik 6">
-            <a:extLst>
-              <a:ext uri="{FF2B5EF4-FFF2-40B4-BE49-F238E27FC236}">
-                <a16:creationId xmlns:a16="http://schemas.microsoft.com/office/drawing/2014/main" id="{61F4E373-2C2B-6E1E-1A93-873EB9700FC5}"/>
+          <p:cNvPr id="5" name="Grafik 4">
+            <a:extLst>
+              <a:ext uri="{FF2B5EF4-FFF2-40B4-BE49-F238E27FC236}">
+                <a16:creationId xmlns:a16="http://schemas.microsoft.com/office/drawing/2014/main" id="{3EB5EBE6-E117-3590-5861-BD93F4B97594}"/>
               </a:ext>
             </a:extLst>
           </p:cNvPr>
@@ -3537,10 +3375,10 @@
       </p:pic>
       <p:pic>
         <p:nvPicPr>
-          <p:cNvPr id="18" name="Grafik 17">
-            <a:extLst>
-              <a:ext uri="{FF2B5EF4-FFF2-40B4-BE49-F238E27FC236}">
-                <a16:creationId xmlns:a16="http://schemas.microsoft.com/office/drawing/2014/main" id="{4BDCD5EC-FD1F-205D-3436-4F4BF6862725}"/>
+          <p:cNvPr id="7" name="Grafik 6">
+            <a:extLst>
+              <a:ext uri="{FF2B5EF4-FFF2-40B4-BE49-F238E27FC236}">
+                <a16:creationId xmlns:a16="http://schemas.microsoft.com/office/drawing/2014/main" id="{FB7775DD-8485-FB04-3C19-0D82F6EDD063}"/>
               </a:ext>
             </a:extLst>
           </p:cNvPr>
@@ -3557,8 +3395,8 @@
         </p:blipFill>
         <p:spPr>
           <a:xfrm>
-            <a:off x="412555" y="2262282"/>
-            <a:ext cx="4723895" cy="661988"/>
+            <a:off x="500063" y="2843728"/>
+            <a:ext cx="3959527" cy="885824"/>
           </a:xfrm>
           <a:prstGeom prst="rect">
             <a:avLst/>
@@ -3567,10 +3405,10 @@
       </p:pic>
       <p:pic>
         <p:nvPicPr>
-          <p:cNvPr id="20" name="Grafik 19">
-            <a:extLst>
-              <a:ext uri="{FF2B5EF4-FFF2-40B4-BE49-F238E27FC236}">
-                <a16:creationId xmlns:a16="http://schemas.microsoft.com/office/drawing/2014/main" id="{28A60721-C8D8-FF6D-83AB-E52FA151535D}"/>
+          <p:cNvPr id="9" name="Grafik 8">
+            <a:extLst>
+              <a:ext uri="{FF2B5EF4-FFF2-40B4-BE49-F238E27FC236}">
+                <a16:creationId xmlns:a16="http://schemas.microsoft.com/office/drawing/2014/main" id="{FBC71EE8-C208-5DA8-0C1C-466B251F72C8}"/>
               </a:ext>
             </a:extLst>
           </p:cNvPr>
@@ -3587,8 +3425,8 @@
         </p:blipFill>
         <p:spPr>
           <a:xfrm>
-            <a:off x="381321" y="2843212"/>
-            <a:ext cx="4874488" cy="1090519"/>
+            <a:off x="500063" y="2257940"/>
+            <a:ext cx="4587956" cy="642938"/>
           </a:xfrm>
           <a:prstGeom prst="rect">
             <a:avLst/>
@@ -3597,11 +3435,11 @@
       </p:pic>
       <p:pic>
         <p:nvPicPr>
-          <p:cNvPr id="22" name="Aufgezeichneter Sound">
+          <p:cNvPr id="10" name="WhatsApp Audio 2026-08-23 at 10.35.15">
             <a:hlinkClick r:id="" action="ppaction://media"/>
             <a:extLst>
               <a:ext uri="{FF2B5EF4-FFF2-40B4-BE49-F238E27FC236}">
-                <a16:creationId xmlns:a16="http://schemas.microsoft.com/office/drawing/2014/main" id="{68359144-CA39-E04F-0ECB-B62DF2470048}"/>
+                <a16:creationId xmlns:a16="http://schemas.microsoft.com/office/drawing/2014/main" id="{70EF9036-61A1-CA5D-CAE8-80E1C987D7CB}"/>
               </a:ext>
             </a:extLst>
           </p:cNvPr>
@@ -3625,7 +3463,7 @@
         </p:blipFill>
         <p:spPr>
           <a:xfrm>
-            <a:off x="-722120" y="3124200"/>
+            <a:off x="-854773" y="2981840"/>
             <a:ext cx="609600" cy="609600"/>
           </a:xfrm>
           <a:prstGeom prst="rect">
@@ -3636,7 +3474,7 @@
     </p:spTree>
     <p:extLst>
       <p:ext uri="{BB962C8B-B14F-4D97-AF65-F5344CB8AC3E}">
-        <p14:creationId xmlns:p14="http://schemas.microsoft.com/office/powerpoint/2010/main" val="2952499640"/>
+        <p14:creationId xmlns:p14="http://schemas.microsoft.com/office/powerpoint/2010/main" val="1446367801"/>
       </p:ext>
     </p:extLst>
   </p:cSld>
@@ -3677,7 +3515,7 @@
                                           </p:stCondLst>
                                         </p:cTn>
                                         <p:tgtEl>
-                                          <p:spTgt spid="20"/>
+                                          <p:spTgt spid="7"/>
                                         </p:tgtEl>
                                         <p:attrNameLst>
                                           <p:attrName>style.visibility</p:attrName>
@@ -3698,9 +3536,9 @@
                                   <p:childTnLst>
                                     <p:cmd type="call" cmd="playFrom(0.0)">
                                       <p:cBhvr>
-                                        <p:cTn id="8" dur="17834" fill="hold"/>
+                                        <p:cTn id="8" dur="16298" fill="hold"/>
                                         <p:tgtEl>
-                                          <p:spTgt spid="22"/>
+                                          <p:spTgt spid="10"/>
                                         </p:tgtEl>
                                       </p:cBhvr>
                                     </p:cmd>
@@ -3745,7 +3583,7 @@
                   </p:endCondLst>
                 </p:cTn>
                 <p:tgtEl>
-                  <p:spTgt spid="22"/>
+                  <p:spTgt spid="10"/>
                 </p:tgtEl>
               </p:cMediaNode>
             </p:audio>
@@ -3754,6 +3592,104 @@
       </p:par>
     </p:tnLst>
   </p:timing>
+</p:sld>
+</file>
+
+<file path=ppt/slides/slide2.xml><?xml version="1.0" encoding="utf-8"?>
+<p:sld xmlns:a="http://schemas.openxmlformats.org/drawingml/2006/main" xmlns:r="http://schemas.openxmlformats.org/officeDocument/2006/relationships" xmlns:p="http://schemas.openxmlformats.org/presentationml/2006/main">
+  <p:cSld>
+    <p:bg>
+      <p:bgPr>
+        <a:solidFill>
+          <a:schemeClr val="bg1"/>
+        </a:solidFill>
+        <a:effectLst/>
+      </p:bgPr>
+    </p:bg>
+    <p:spTree>
+      <p:nvGrpSpPr>
+        <p:cNvPr id="1" name=""/>
+        <p:cNvGrpSpPr/>
+        <p:nvPr/>
+      </p:nvGrpSpPr>
+      <p:grpSpPr>
+        <a:xfrm>
+          <a:off x="0" y="0"/>
+          <a:ext cx="0" cy="0"/>
+          <a:chOff x="0" y="0"/>
+          <a:chExt cx="0" cy="0"/>
+        </a:xfrm>
+      </p:grpSpPr>
+      <p:pic>
+        <p:nvPicPr>
+          <p:cNvPr id="7" name="Grafik 6">
+            <a:extLst>
+              <a:ext uri="{FF2B5EF4-FFF2-40B4-BE49-F238E27FC236}">
+                <a16:creationId xmlns:a16="http://schemas.microsoft.com/office/drawing/2014/main" id="{4975F745-1832-0A73-25EA-B8D0F573BF09}"/>
+              </a:ext>
+            </a:extLst>
+          </p:cNvPr>
+          <p:cNvPicPr>
+            <a:picLocks noChangeAspect="1"/>
+          </p:cNvPicPr>
+          <p:nvPr/>
+        </p:nvPicPr>
+        <p:blipFill>
+          <a:blip r:embed="rId2"/>
+          <a:stretch>
+            <a:fillRect/>
+          </a:stretch>
+        </p:blipFill>
+        <p:spPr>
+          <a:xfrm>
+            <a:off x="484632" y="1665979"/>
+            <a:ext cx="6716272" cy="3526042"/>
+          </a:xfrm>
+          <a:prstGeom prst="rect">
+            <a:avLst/>
+          </a:prstGeom>
+        </p:spPr>
+      </p:pic>
+      <p:pic>
+        <p:nvPicPr>
+          <p:cNvPr id="5" name="Grafik 4">
+            <a:extLst>
+              <a:ext uri="{FF2B5EF4-FFF2-40B4-BE49-F238E27FC236}">
+                <a16:creationId xmlns:a16="http://schemas.microsoft.com/office/drawing/2014/main" id="{D56CDDD2-CBE0-4482-DC1A-6E39A642831E}"/>
+              </a:ext>
+            </a:extLst>
+          </p:cNvPr>
+          <p:cNvPicPr>
+            <a:picLocks noChangeAspect="1"/>
+          </p:cNvPicPr>
+          <p:nvPr/>
+        </p:nvPicPr>
+        <p:blipFill>
+          <a:blip r:embed="rId3"/>
+          <a:stretch>
+            <a:fillRect/>
+          </a:stretch>
+        </p:blipFill>
+        <p:spPr>
+          <a:xfrm>
+            <a:off x="7534655" y="1342644"/>
+            <a:ext cx="4172712" cy="4172712"/>
+          </a:xfrm>
+          <a:prstGeom prst="rect">
+            <a:avLst/>
+          </a:prstGeom>
+        </p:spPr>
+      </p:pic>
+    </p:spTree>
+    <p:extLst>
+      <p:ext uri="{BB962C8B-B14F-4D97-AF65-F5344CB8AC3E}">
+        <p14:creationId xmlns:p14="http://schemas.microsoft.com/office/powerpoint/2010/main" val="146899649"/>
+      </p:ext>
+    </p:extLst>
+  </p:cSld>
+  <p:clrMapOvr>
+    <a:masterClrMapping/>
+  </p:clrMapOvr>
 </p:sld>
 </file>
 

</xml_diff>